<commit_message>
minor update to BMC
</commit_message>
<xml_diff>
--- a/Classes/BUS 500, Foundations for Business Impact/Week 2/BAVARIAN.CYRUS.BMC.pptx
+++ b/Classes/BUS 500, Foundations for Business Impact/Week 2/BAVARIAN.CYRUS.BMC.pptx
@@ -453,7 +453,7 @@
           <a:p>
             <a:fld id="{C96F2922-797C-45C2-9475-1803A9D22A0A}" type="datetimeFigureOut">
               <a:rPr lang="en-US" smtClean="0"/>
-              <a:t>9/4/2026</a:t>
+              <a:t>9/5/2026</a:t>
             </a:fld>
             <a:endParaRPr lang="en-US"/>
           </a:p>
@@ -1105,12 +1105,16 @@
               <a:defRPr/>
             </a:pPr>
             <a:r>
-              <a:rPr lang="en-US" b="1" dirty="0"/>
-              <a:t>Customer Segments: </a:t>
+              <a:rPr lang="en-US" b="1"/>
+              <a:t>Overview: </a:t>
+            </a:r>
+            <a:r>
+              <a:rPr lang="en-US" b="0"/>
+              <a:t>There </a:t>
             </a:r>
             <a:r>
               <a:rPr lang="en-US" b="0" dirty="0"/>
-              <a:t>There are not many smartphone makers (anymore) and the ones that do exist demand excellence in the components that make up their phone. Entire organizations, supply chains, and global resources are used to created a </a:t>
+              <a:t>are not many smartphone makers (anymore) and the ones that do exist demand excellence in the components that make up their phone. Entire organizations, supply chains, and global resources are used to created a </a:t>
             </a:r>
             <a:r>
               <a:rPr lang="en-US" b="0" dirty="0" err="1"/>

</xml_diff>

<commit_message>
BMC updated finalish ddraft
</commit_message>
<xml_diff>
--- a/Classes/BUS 500, Foundations for Business Impact/Week 2/BAVARIAN.CYRUS.BMC.pptx
+++ b/Classes/BUS 500, Foundations for Business Impact/Week 2/BAVARIAN.CYRUS.BMC.pptx
@@ -7,7 +7,7 @@
     <p:sldMasterId id="2147483670" r:id="rId3"/>
   </p:sldMasterIdLst>
   <p:notesMasterIdLst>
-    <p:notesMasterId r:id="rId11"/>
+    <p:notesMasterId r:id="rId12"/>
   </p:notesMasterIdLst>
   <p:sldIdLst>
     <p:sldId id="495" r:id="rId4"/>
@@ -17,6 +17,7 @@
     <p:sldId id="2088198109" r:id="rId8"/>
     <p:sldId id="490" r:id="rId9"/>
     <p:sldId id="494" r:id="rId10"/>
+    <p:sldId id="2088198110" r:id="rId11"/>
   </p:sldIdLst>
   <p:sldSz cx="12192000" cy="6858000"/>
   <p:notesSz cx="6858000" cy="9144000"/>
@@ -1105,24 +1106,12 @@
               <a:defRPr/>
             </a:pPr>
             <a:r>
-              <a:rPr lang="en-US" b="1"/>
+              <a:rPr lang="en-US" b="1" dirty="0"/>
               <a:t>Overview: </a:t>
             </a:r>
             <a:r>
-              <a:rPr lang="en-US" b="0"/>
-              <a:t>There </a:t>
-            </a:r>
-            <a:r>
-              <a:rPr lang="en-US" b="0" dirty="0"/>
-              <a:t>are not many smartphone makers (anymore) and the ones that do exist demand excellence in the components that make up their phone. Entire organizations, supply chains, and global resources are used to created a </a:t>
-            </a:r>
-            <a:r>
-              <a:rPr lang="en-US" b="0" dirty="0" err="1"/>
-              <a:t>speciality</a:t>
-            </a:r>
-            <a:r>
-              <a:rPr lang="en-US" b="0" dirty="0"/>
-              <a:t> product which is used strictly in smart phones. This massive effort to create the worlds best chip dedicated to a single function provides an interesting perspective this market, and the companies that support it.</a:t>
+              <a:rPr lang="en-US" dirty="0"/>
+              <a:t>WSD builds a specialty product for a small set of smartphone OEMs. There are not many of those customers left, and they demand components that will not miss a phone launch. That focus is the business model: we ignore almost every other use of RF silicon so we can serve this niche.</a:t>
             </a:r>
           </a:p>
           <a:p>
@@ -1165,31 +1154,15 @@
             </a:pPr>
             <a:r>
               <a:rPr lang="en-US" b="0" dirty="0"/>
-              <a:t>Customer Segments: Many organizations attempt to offer a variety of products to reach many customers, thereby targeting multiple customer segments and enhancing their ability to profit. </a:t>
+              <a:t>Customer Segments: WSD operates in a niche B2B market. Leading smartphone makers like </a:t>
             </a:r>
             <a:r>
               <a:rPr lang="en-US" b="0" dirty="0" err="1"/>
-              <a:t>SmartPhone</a:t>
+              <a:t>Samung</a:t>
             </a:r>
             <a:r>
               <a:rPr lang="en-US" b="0" dirty="0"/>
-              <a:t> technology is distinctly different. Apple is one of the largest manufacturers of </a:t>
-            </a:r>
-            <a:r>
-              <a:rPr lang="en-US" b="0" dirty="0" err="1"/>
-              <a:t>SmartPhones</a:t>
-            </a:r>
-            <a:r>
-              <a:rPr lang="en-US" b="0" dirty="0"/>
-              <a:t> on the earth whose products reach millions of customers. </a:t>
-            </a:r>
-            <a:r>
-              <a:rPr lang="en-US" b="0" dirty="0" err="1"/>
-              <a:t>Broadcoms</a:t>
-            </a:r>
-            <a:r>
-              <a:rPr lang="en-US" b="0" dirty="0"/>
-              <a:t> entire business model depends highly on positioning it’s product for that particular customer. Therefor our customer segments are tightly focused on the leading smartphone manufacturers. Because our product is so specialized to target the needs of Apple, this allows us to ignore other customer segments ensuring that our product meets the needs of Apple. Apple’s multi-year roadmaps ensure our product ensures apples competitiveness among the market. Apple pays Broadcom a substantial amount to ensure that we remain as their primary customer segment</a:t>
+              <a:t>, Google, and Apple. Apple is the primary customer. Our specialization offers distinction from mass-markets, multi-sided markets, and diversified markets. We do one great thing for specific customers. However if that customer is gone, it hits us hard. </a:t>
             </a:r>
           </a:p>
           <a:p>
@@ -1232,15 +1205,7 @@
             </a:pPr>
             <a:r>
               <a:rPr lang="en-US" b="0" dirty="0"/>
-              <a:t>Value Proposition: To achieve a title of worlds-best smartphone requires worlds-best components. </a:t>
-            </a:r>
-            <a:r>
-              <a:rPr lang="en-US" b="0" dirty="0" err="1"/>
-              <a:t>Broadcoms</a:t>
-            </a:r>
-            <a:r>
-              <a:rPr lang="en-US" b="0" dirty="0"/>
-              <a:t> value proposition not only includes offering a worlds best RF filter, but our manufacturing capabilities ensure we are able to meet customer demands. Additionally our ability to quickly adopt new technologies in our manufacturing process which improves quality and yield allows us to keep up with new technological demands and industry best practices. The bundle of quality, reliability, speed is central to the value proposition we offer to our customers.</a:t>
+              <a:t>Value Proposition: The mix of solutions that offer value to our customers includes customization, performance, risk reduction. We get the job done. Broadcom WSD offers RF filters that meet OEM specs and is able to offer high volume on the customers calendar.</a:t>
             </a:r>
           </a:p>
           <a:p>
@@ -1283,39 +1248,7 @@
             </a:pPr>
             <a:r>
               <a:rPr lang="en-US" b="0" dirty="0"/>
-              <a:t>Channels: As a supplier for smart phone manufacturers, our products do not hit store shelves. Broadcom offers a B2B Direct channel for delivering components to </a:t>
-            </a:r>
-            <a:r>
-              <a:rPr lang="en-US" b="0" dirty="0" err="1"/>
-              <a:t>SmartPhone</a:t>
-            </a:r>
-            <a:r>
-              <a:rPr lang="en-US" b="0" dirty="0"/>
-              <a:t> manufacturers immediately after packaging. This direct line of access to our product ensures our company </a:t>
-            </a:r>
-            <a:r>
-              <a:rPr lang="en-US" b="0" dirty="0" err="1"/>
-              <a:t>mantains</a:t>
-            </a:r>
-            <a:r>
-              <a:rPr lang="en-US" b="0" dirty="0"/>
-              <a:t> direct contact with our customer which offers additional value ensuring that problems along the supply chain are identified immediately and resolved. Smartphone manufacturers become aware of our products during competitions where suppliers compete to win sockets specified by the Smartphone </a:t>
-            </a:r>
-            <a:r>
-              <a:rPr lang="en-US" b="0" dirty="0" err="1"/>
-              <a:t>manufactuere</a:t>
-            </a:r>
-            <a:r>
-              <a:rPr lang="en-US" b="0" dirty="0"/>
-              <a:t>. Companies who can quantify and qualify the value of their product tend to win the most design sockets. During the competition, quality and reliability are evaluated by the customer who decides whether the product meets their design specs. Apple purchases directly from Broadcom in a B2B direct manner. Our products are delivered directly to apple after packaging. Components that fail or show signs of failure during the development of new phones are communicated back to the Broadcom for investigation. Theis investigation </a:t>
-            </a:r>
-            <a:r>
-              <a:rPr lang="en-US" b="0" dirty="0" err="1"/>
-              <a:t>typiclay</a:t>
-            </a:r>
-            <a:r>
-              <a:rPr lang="en-US" b="0" dirty="0"/>
-              <a:t> involves a deep dive into the manufacturing process to identify when and where exactly quality and defects occurred.</a:t>
+              <a:t>Channels:</a:t>
             </a:r>
           </a:p>
           <a:p>
@@ -1336,7 +1269,10 @@
               <a:tabLst/>
               <a:defRPr/>
             </a:pPr>
-            <a:endParaRPr lang="en-US" b="0" dirty="0"/>
+            <a:r>
+              <a:rPr lang="en-US" b="0" dirty="0"/>
+              <a:t>Customer Relationships: Broadcom and leading smartphone suppliers require a very close relationship in order to ensure quality and meet the supply demands of smartphones. </a:t>
+            </a:r>
           </a:p>
           <a:p>
             <a:pPr marL="0" marR="0" lvl="0" indent="0" algn="l" defTabSz="1828785" rtl="0" eaLnBrk="1" fontAlgn="auto" latinLnBrk="0" hangingPunct="1">
@@ -1358,15 +1294,7 @@
             </a:pPr>
             <a:r>
               <a:rPr lang="en-US" b="0" dirty="0"/>
-              <a:t>Customer Relationships: Broadcom and leading smartphone suppliers require a very close relationship in order to ensure quality and meet the supply demands of smartphones. Every year a new smartphone comes out which requires Broadcom to ensure that it can meet to supply needs and technology expectations needed for this years products. Therefor, smartphone supplier and Broadcom work closely in a co-creation relationship where both customer and supplier work together to define multi-year design specs and joint roadmaps. This symbiotic relationship ensures that Broadcom offers dedicated assistance to the </a:t>
-            </a:r>
-            <a:r>
-              <a:rPr lang="en-US" b="0" dirty="0" err="1"/>
-              <a:t>custuomer</a:t>
-            </a:r>
-            <a:r>
-              <a:rPr lang="en-US" b="0" dirty="0"/>
-              <a:t> to manage and handle quality concerns while the costumer offers production roadmaps that allow for Broadcom to maintain operations.</a:t>
+              <a:t>Awareness: RFQ competitions, customer sockets</a:t>
             </a:r>
           </a:p>
           <a:p>
@@ -1387,7 +1315,10 @@
               <a:tabLst/>
               <a:defRPr/>
             </a:pPr>
-            <a:endParaRPr lang="en-US" b="0" dirty="0"/>
+            <a:r>
+              <a:rPr lang="en-US" b="0" dirty="0"/>
+              <a:t>Evaluation: customers determines if we meet quality, reliability, and specs</a:t>
+            </a:r>
           </a:p>
           <a:p>
             <a:pPr marL="0" marR="0" lvl="0" indent="0" algn="l" defTabSz="1828785" rtl="0" eaLnBrk="1" fontAlgn="auto" latinLnBrk="0" hangingPunct="1">
@@ -1409,31 +1340,7 @@
             </a:pPr>
             <a:r>
               <a:rPr lang="en-US" b="0" dirty="0"/>
-              <a:t>Revenue Streams: Revenue streams for Broadcom are relatively simple. Our volume of production directly correlates to asset sales. Most often </a:t>
-            </a:r>
-            <a:r>
-              <a:rPr lang="en-US" b="0" dirty="0" err="1"/>
-              <a:t>smarthone</a:t>
-            </a:r>
-            <a:r>
-              <a:rPr lang="en-US" b="0" dirty="0"/>
-              <a:t> suppliers request a target number of products each month to meet the yearly roadmap for supply which goes through </a:t>
-            </a:r>
-            <a:r>
-              <a:rPr lang="en-US" b="0" dirty="0" err="1"/>
-              <a:t>ebs</a:t>
-            </a:r>
-            <a:r>
-              <a:rPr lang="en-US" b="0" dirty="0"/>
-              <a:t> and flows throughout the seasons, typically peaking at the end of the year. </a:t>
-            </a:r>
-            <a:r>
-              <a:rPr lang="en-US" b="0" dirty="0" err="1"/>
-              <a:t>pRoduction</a:t>
-            </a:r>
-            <a:r>
-              <a:rPr lang="en-US" b="0" dirty="0"/>
-              <a:t> volumes are decided on a monthly bases with the customer who is anticipating demand for their product. Higher demand expectations by the smartphone customers equate to higher volume requests to our manufacturing facility. Prices are likely fixed during each production cycle, but depending on many factors during the year the cost of production can change. It’s highly likely that Broadcom and Apple negotiate costs based on current market factors, but likely do not undergo any type of surge pricing.</a:t>
+              <a:t>Purchase: negotiate supply agreements</a:t>
             </a:r>
           </a:p>
           <a:p>
@@ -1454,7 +1361,10 @@
               <a:tabLst/>
               <a:defRPr/>
             </a:pPr>
-            <a:endParaRPr lang="en-US" b="0" dirty="0"/>
+            <a:r>
+              <a:rPr lang="en-US" b="0" dirty="0"/>
+              <a:t>Delivery: fabricate -&gt; package -&gt; OEM</a:t>
+            </a:r>
           </a:p>
           <a:p>
             <a:pPr marL="0" marR="0" lvl="0" indent="0" algn="l" defTabSz="1828785" rtl="0" eaLnBrk="1" fontAlgn="auto" latinLnBrk="0" hangingPunct="1">
@@ -1476,23 +1386,7 @@
             </a:pPr>
             <a:r>
               <a:rPr lang="en-US" b="0" dirty="0"/>
-              <a:t>Key resources: As a manufacturing company we are highly dependent on the key resources that keep our 24/7 production line going. Physical resources include the actual building, equipment, chemicals, and consumables. Intellectual resources include our engineering capabilities, </a:t>
-            </a:r>
-            <a:r>
-              <a:rPr lang="en-US" b="0" dirty="0" err="1"/>
-              <a:t>propiatary</a:t>
-            </a:r>
-            <a:r>
-              <a:rPr lang="en-US" b="0" dirty="0"/>
-              <a:t> knowledge of RF tech, and patents that keep our product and process cutting edge. Our human resources include the directors, </a:t>
-            </a:r>
-            <a:r>
-              <a:rPr lang="en-US" b="0" dirty="0" err="1"/>
-              <a:t>empoloyees</a:t>
-            </a:r>
-            <a:r>
-              <a:rPr lang="en-US" b="0" dirty="0"/>
-              <a:t>, and contractors that keep the production facility focused and operational. Financial resources are critical which demand massive amounts of available cash to operate, pay for salaries, utilities, permits, and taxes.</a:t>
+              <a:t>Post-Sales: Customer has a direct line to fix problems</a:t>
             </a:r>
           </a:p>
           <a:p>
@@ -1535,23 +1429,23 @@
             </a:pPr>
             <a:r>
               <a:rPr lang="en-US" b="0" dirty="0"/>
-              <a:t>Key </a:t>
+              <a:t>Revenue Streams: Revenue streams for Broadcom are relatively simple. Our volume of production directly correlates to asset sales. Most often </a:t>
             </a:r>
             <a:r>
               <a:rPr lang="en-US" b="0" dirty="0" err="1"/>
-              <a:t>Activies</a:t>
+              <a:t>smarthone</a:t>
             </a:r>
             <a:r>
               <a:rPr lang="en-US" b="0" dirty="0"/>
-              <a:t>: Broadcom started out as a R&amp;D company and slowed morphed into a high-volume production facility. We currently supply both to our customers which places us at odds with competitive advantage against product volume all within the same walls of the company. Our key </a:t>
+              <a:t> suppliers request a target number of products each month to meet the yearly roadmap for supply which goes through </a:t>
             </a:r>
             <a:r>
               <a:rPr lang="en-US" b="0" dirty="0" err="1"/>
-              <a:t>activies</a:t>
+              <a:t>ebs</a:t>
             </a:r>
             <a:r>
               <a:rPr lang="en-US" b="0" dirty="0"/>
-              <a:t> can be summarized as high-volume manufacturing as well as R&amp;D. Both together demand a constant focus on quality management, yield innovations, and new product introductions.</a:t>
+              <a:t> and flows throughout the seasons, typically peaking at the end of the year. Pricing is negotiated, fixed into a contract, and lasts for the build cycle. No surge-pricing.</a:t>
             </a:r>
           </a:p>
           <a:p>
@@ -1594,7 +1488,35 @@
             </a:pPr>
             <a:r>
               <a:rPr lang="en-US" b="0" dirty="0"/>
-              <a:t>Key Partnerships: Our relationships with our key partners is critical for the ongoing production capability of our companies. We are highly reliant on chemical and equipment manufacturers that are used on the process line to actually build the product. Contractors and logistics partners ensure that the fab space is operational in a 24/7 running environment. One the product is built, our packaging partners build into a product that our customer can integrate into their phone design.</a:t>
+              <a:t>Key resources: As a manufacturing company we are highly dependent on the key resources that keep our 24/7 production line going. </a:t>
+            </a:r>
+          </a:p>
+          <a:p>
+            <a:pPr lvl="0"/>
+            <a:r>
+              <a:rPr lang="en-US" dirty="0"/>
+              <a:t>Physical: fab, tools, chemicals/consumables we inventory.</a:t>
+            </a:r>
+          </a:p>
+          <a:p>
+            <a:pPr lvl="0"/>
+            <a:r>
+              <a:rPr lang="en-US" dirty="0"/>
+              <a:t>Intellectual: process recipes, RF know-how, patents.</a:t>
+            </a:r>
+          </a:p>
+          <a:p>
+            <a:pPr lvl="0"/>
+            <a:r>
+              <a:rPr lang="en-US" dirty="0"/>
+              <a:t>Human: employees who run the 24/7 line.</a:t>
+            </a:r>
+          </a:p>
+          <a:p>
+            <a:pPr lvl="0"/>
+            <a:r>
+              <a:rPr lang="en-US" dirty="0"/>
+              <a:t>Financial: capex and working capital (tools, expansion, utilities).</a:t>
             </a:r>
           </a:p>
           <a:p>
@@ -1635,10 +1557,7 @@
               <a:tabLst/>
               <a:defRPr/>
             </a:pPr>
-            <a:r>
-              <a:rPr lang="en-US" b="0" dirty="0"/>
-              <a:t>Cost Structure: There are several costs associated with our manufacturing facility but they can be summarized into relatively large buckets. Employee salaries ensure we have the right human resources needed to design, build, and maintain our operation. Equipment, chemical, and consumables are needed to actually build the product on the production floor. Contractors ensure that the facility remains operational. </a:t>
-            </a:r>
+            <a:endParaRPr lang="en-US" b="0" dirty="0"/>
           </a:p>
           <a:p>
             <a:pPr marL="0" marR="0" lvl="0" indent="0" algn="l" defTabSz="1828785" rtl="0" eaLnBrk="1" fontAlgn="auto" latinLnBrk="0" hangingPunct="1">
@@ -1658,7 +1577,224 @@
               <a:tabLst/>
               <a:defRPr/>
             </a:pPr>
+            <a:r>
+              <a:rPr lang="en-US" b="0" dirty="0"/>
+              <a:t>Key </a:t>
+            </a:r>
+            <a:r>
+              <a:rPr lang="en-US" b="0" dirty="0" err="1"/>
+              <a:t>Activies</a:t>
+            </a:r>
+            <a:r>
+              <a:rPr lang="en-US" b="0" dirty="0"/>
+              <a:t>: Broadcom started out as a R&amp;D company and slowly morphed into a high-volume production facility. We now offer both R&amp;D and high-Volume which becomes a challenge between maintaining competitive advantage and against high volume production. Our key </a:t>
+            </a:r>
+            <a:r>
+              <a:rPr lang="en-US" b="0" dirty="0" err="1"/>
+              <a:t>activies</a:t>
+            </a:r>
+            <a:r>
+              <a:rPr lang="en-US" b="0" dirty="0"/>
+              <a:t> can be summarized as high-volume manufacturing as well as R&amp;D. Both together demand a constant focus on quality management, yield innovations, and new product introductions.</a:t>
+            </a:r>
+          </a:p>
+          <a:p>
+            <a:pPr marL="0" marR="0" lvl="0" indent="0" algn="l" defTabSz="1828785" rtl="0" eaLnBrk="1" fontAlgn="auto" latinLnBrk="0" hangingPunct="1">
+              <a:lnSpc>
+                <a:spcPct val="100000"/>
+              </a:lnSpc>
+              <a:spcBef>
+                <a:spcPts val="0"/>
+              </a:spcBef>
+              <a:spcAft>
+                <a:spcPts val="0"/>
+              </a:spcAft>
+              <a:buClrTx/>
+              <a:buSzTx/>
+              <a:buFontTx/>
+              <a:buNone/>
+              <a:tabLst/>
+              <a:defRPr/>
+            </a:pPr>
             <a:endParaRPr lang="en-US" b="0" dirty="0"/>
+          </a:p>
+          <a:p>
+            <a:pPr marL="0" marR="0" lvl="0" indent="0" algn="l" defTabSz="1828785" rtl="0" eaLnBrk="1" fontAlgn="auto" latinLnBrk="0" hangingPunct="1">
+              <a:lnSpc>
+                <a:spcPct val="100000"/>
+              </a:lnSpc>
+              <a:spcBef>
+                <a:spcPts val="0"/>
+              </a:spcBef>
+              <a:spcAft>
+                <a:spcPts val="0"/>
+              </a:spcAft>
+              <a:buClrTx/>
+              <a:buSzTx/>
+              <a:buFontTx/>
+              <a:buNone/>
+              <a:tabLst/>
+              <a:defRPr/>
+            </a:pPr>
+            <a:r>
+              <a:rPr lang="en-US" b="0" dirty="0"/>
+              <a:t>Key Partnerships: Broadcom WSD is reliant on chemical and equipment manufacturers that are used on the process line to actually build the product. Contractors and logistics partners ensure that the fab space is operational in a 24/7 running environment. Packaging partners build our product into a package that can fit inside our customers phone.</a:t>
+            </a:r>
+          </a:p>
+          <a:p>
+            <a:pPr marL="0" marR="0" lvl="0" indent="0" algn="l" defTabSz="1828785" rtl="0" eaLnBrk="1" fontAlgn="auto" latinLnBrk="0" hangingPunct="1">
+              <a:lnSpc>
+                <a:spcPct val="100000"/>
+              </a:lnSpc>
+              <a:spcBef>
+                <a:spcPts val="0"/>
+              </a:spcBef>
+              <a:spcAft>
+                <a:spcPts val="0"/>
+              </a:spcAft>
+              <a:buClrTx/>
+              <a:buSzTx/>
+              <a:buFontTx/>
+              <a:buNone/>
+              <a:tabLst/>
+              <a:defRPr/>
+            </a:pPr>
+            <a:endParaRPr lang="en-US" b="0" dirty="0"/>
+          </a:p>
+          <a:p>
+            <a:pPr marL="0" marR="0" lvl="0" indent="0" algn="l" defTabSz="1828785" rtl="0" eaLnBrk="1" fontAlgn="auto" latinLnBrk="0" hangingPunct="1">
+              <a:lnSpc>
+                <a:spcPct val="100000"/>
+              </a:lnSpc>
+              <a:spcBef>
+                <a:spcPts val="0"/>
+              </a:spcBef>
+              <a:spcAft>
+                <a:spcPts val="0"/>
+              </a:spcAft>
+              <a:buClrTx/>
+              <a:buSzTx/>
+              <a:buFontTx/>
+              <a:buNone/>
+              <a:tabLst/>
+              <a:defRPr/>
+            </a:pPr>
+            <a:r>
+              <a:rPr lang="en-US" b="0" dirty="0"/>
+              <a:t>Cost Structure:</a:t>
+            </a:r>
+          </a:p>
+          <a:p>
+            <a:pPr marL="0" marR="0" lvl="0" indent="0" algn="l" defTabSz="1828785" rtl="0" eaLnBrk="1" fontAlgn="auto" latinLnBrk="0" hangingPunct="1">
+              <a:lnSpc>
+                <a:spcPct val="100000"/>
+              </a:lnSpc>
+              <a:spcBef>
+                <a:spcPts val="0"/>
+              </a:spcBef>
+              <a:spcAft>
+                <a:spcPts val="0"/>
+              </a:spcAft>
+              <a:buClrTx/>
+              <a:buSzTx/>
+              <a:buFontTx/>
+              <a:buNone/>
+              <a:tabLst/>
+              <a:defRPr/>
+            </a:pPr>
+            <a:r>
+              <a:rPr lang="en-US" b="0" dirty="0"/>
+              <a:t>Fixed costs: Fab, tools, employees</a:t>
+            </a:r>
+          </a:p>
+          <a:p>
+            <a:pPr marL="0" marR="0" lvl="0" indent="0" algn="l" defTabSz="1828785" rtl="0" eaLnBrk="1" fontAlgn="auto" latinLnBrk="0" hangingPunct="1">
+              <a:lnSpc>
+                <a:spcPct val="100000"/>
+              </a:lnSpc>
+              <a:spcBef>
+                <a:spcPts val="0"/>
+              </a:spcBef>
+              <a:spcAft>
+                <a:spcPts val="0"/>
+              </a:spcAft>
+              <a:buClrTx/>
+              <a:buSzTx/>
+              <a:buFontTx/>
+              <a:buNone/>
+              <a:tabLst/>
+              <a:defRPr/>
+            </a:pPr>
+            <a:r>
+              <a:rPr lang="en-US" b="0" dirty="0"/>
+              <a:t>Variable costs: chemicals, wafers, overtime,</a:t>
+            </a:r>
+          </a:p>
+          <a:p>
+            <a:pPr marL="0" marR="0" lvl="0" indent="0" algn="l" defTabSz="1828785" rtl="0" eaLnBrk="1" fontAlgn="auto" latinLnBrk="0" hangingPunct="1">
+              <a:lnSpc>
+                <a:spcPct val="100000"/>
+              </a:lnSpc>
+              <a:spcBef>
+                <a:spcPts val="0"/>
+              </a:spcBef>
+              <a:spcAft>
+                <a:spcPts val="0"/>
+              </a:spcAft>
+              <a:buClrTx/>
+              <a:buSzTx/>
+              <a:buFontTx/>
+              <a:buNone/>
+              <a:tabLst/>
+              <a:defRPr/>
+            </a:pPr>
+            <a:r>
+              <a:rPr lang="en-US" b="0" dirty="0"/>
+              <a:t>Economies of scale: high utilization, high yield offer the highest profit. Downtime and quality problems hurt.</a:t>
+            </a:r>
+          </a:p>
+          <a:p>
+            <a:pPr marL="0" marR="0" lvl="0" indent="0" algn="l" defTabSz="1828785" rtl="0" eaLnBrk="1" fontAlgn="auto" latinLnBrk="0" hangingPunct="1">
+              <a:lnSpc>
+                <a:spcPct val="100000"/>
+              </a:lnSpc>
+              <a:spcBef>
+                <a:spcPts val="0"/>
+              </a:spcBef>
+              <a:spcAft>
+                <a:spcPts val="0"/>
+              </a:spcAft>
+              <a:buClrTx/>
+              <a:buSzTx/>
+              <a:buFontTx/>
+              <a:buNone/>
+              <a:tabLst/>
+              <a:defRPr/>
+            </a:pPr>
+            <a:endParaRPr lang="en-US" b="0" dirty="0"/>
+          </a:p>
+          <a:p>
+            <a:pPr marL="0" marR="0" lvl="0" indent="0" algn="l" defTabSz="1828785" rtl="0" eaLnBrk="1" fontAlgn="auto" latinLnBrk="0" hangingPunct="1">
+              <a:lnSpc>
+                <a:spcPct val="100000"/>
+              </a:lnSpc>
+              <a:spcBef>
+                <a:spcPts val="0"/>
+              </a:spcBef>
+              <a:spcAft>
+                <a:spcPts val="0"/>
+              </a:spcAft>
+              <a:buClrTx/>
+              <a:buSzTx/>
+              <a:buFontTx/>
+              <a:buNone/>
+              <a:tabLst/>
+              <a:defRPr/>
+            </a:pPr>
+            <a:r>
+              <a:rPr lang="en-US" b="0" dirty="0"/>
+              <a:t>We are a value driven company – Apple sees our value in the reliability, quality, and performance of our product.  </a:t>
+            </a:r>
           </a:p>
           <a:p>
             <a:pPr marL="0" marR="0" lvl="0" indent="0" algn="l" defTabSz="1828785" rtl="0" eaLnBrk="1" fontAlgn="auto" latinLnBrk="0" hangingPunct="1">
@@ -1780,12 +1916,12 @@
               <a:defRPr/>
             </a:pPr>
             <a:r>
-              <a:rPr lang="en-US"/>
+              <a:rPr lang="en-US" dirty="0"/>
               <a:t>Complete this slide with the Business Model Canvas assignment</a:t>
             </a:r>
           </a:p>
           <a:p>
-            <a:endParaRPr lang="en-US"/>
+            <a:endParaRPr lang="en-US" dirty="0"/>
           </a:p>
         </p:txBody>
       </p:sp>
@@ -1817,6 +1953,138 @@
     <p:extLst>
       <p:ext uri="{BB962C8B-B14F-4D97-AF65-F5344CB8AC3E}">
         <p14:creationId xmlns:p14="http://schemas.microsoft.com/office/powerpoint/2010/main" val="2884476982"/>
+      </p:ext>
+    </p:extLst>
+  </p:cSld>
+  <p:clrMapOvr>
+    <a:masterClrMapping/>
+  </p:clrMapOvr>
+</p:notes>
+</file>
+
+<file path=ppt/notesSlides/notesSlide5.xml><?xml version="1.0" encoding="utf-8"?>
+<p:notes xmlns:a="http://schemas.openxmlformats.org/drawingml/2006/main" xmlns:r="http://schemas.openxmlformats.org/officeDocument/2006/relationships" xmlns:p="http://schemas.openxmlformats.org/presentationml/2006/main">
+  <p:cSld>
+    <p:spTree>
+      <p:nvGrpSpPr>
+        <p:cNvPr id="1" name="">
+          <a:extLst>
+            <a:ext uri="{FF2B5EF4-FFF2-40B4-BE49-F238E27FC236}">
+              <a16:creationId xmlns:a16="http://schemas.microsoft.com/office/drawing/2014/main" id="{70A8D134-19E7-875A-6709-C6C3676F6728}"/>
+            </a:ext>
+          </a:extLst>
+        </p:cNvPr>
+        <p:cNvGrpSpPr/>
+        <p:nvPr/>
+      </p:nvGrpSpPr>
+      <p:grpSpPr>
+        <a:xfrm>
+          <a:off x="0" y="0"/>
+          <a:ext cx="0" cy="0"/>
+          <a:chOff x="0" y="0"/>
+          <a:chExt cx="0" cy="0"/>
+        </a:xfrm>
+      </p:grpSpPr>
+      <p:sp>
+        <p:nvSpPr>
+          <p:cNvPr id="2" name="Slide Image Placeholder 1">
+            <a:extLst>
+              <a:ext uri="{FF2B5EF4-FFF2-40B4-BE49-F238E27FC236}">
+                <a16:creationId xmlns:a16="http://schemas.microsoft.com/office/drawing/2014/main" id="{70E3D5B8-247B-AE15-CD4E-48DB624CE13A}"/>
+              </a:ext>
+            </a:extLst>
+          </p:cNvPr>
+          <p:cNvSpPr>
+            <a:spLocks noGrp="1" noRot="1" noChangeAspect="1"/>
+          </p:cNvSpPr>
+          <p:nvPr>
+            <p:ph type="sldImg"/>
+          </p:nvPr>
+        </p:nvSpPr>
+        <p:spPr/>
+      </p:sp>
+      <p:sp>
+        <p:nvSpPr>
+          <p:cNvPr id="3" name="Notes Placeholder 2">
+            <a:extLst>
+              <a:ext uri="{FF2B5EF4-FFF2-40B4-BE49-F238E27FC236}">
+                <a16:creationId xmlns:a16="http://schemas.microsoft.com/office/drawing/2014/main" id="{DDB08A9C-BB52-60AC-CC23-37A353EE8DE2}"/>
+              </a:ext>
+            </a:extLst>
+          </p:cNvPr>
+          <p:cNvSpPr>
+            <a:spLocks noGrp="1"/>
+          </p:cNvSpPr>
+          <p:nvPr>
+            <p:ph type="body" idx="1"/>
+          </p:nvPr>
+        </p:nvSpPr>
+        <p:spPr/>
+        <p:txBody>
+          <a:bodyPr/>
+          <a:lstStyle/>
+          <a:p>
+            <a:pPr marL="0" marR="0" lvl="0" indent="0" algn="l" defTabSz="1828785" rtl="0" eaLnBrk="1" fontAlgn="auto" latinLnBrk="0" hangingPunct="1">
+              <a:lnSpc>
+                <a:spcPct val="100000"/>
+              </a:lnSpc>
+              <a:spcBef>
+                <a:spcPts val="0"/>
+              </a:spcBef>
+              <a:spcAft>
+                <a:spcPts val="0"/>
+              </a:spcAft>
+              <a:buClrTx/>
+              <a:buSzTx/>
+              <a:buFontTx/>
+              <a:buNone/>
+              <a:tabLst/>
+              <a:defRPr/>
+            </a:pPr>
+            <a:r>
+              <a:rPr lang="en-US" dirty="0"/>
+              <a:t>Complete this slide with the Business Model Canvas assignment</a:t>
+            </a:r>
+          </a:p>
+          <a:p>
+            <a:endParaRPr lang="en-US" dirty="0"/>
+          </a:p>
+        </p:txBody>
+      </p:sp>
+      <p:sp>
+        <p:nvSpPr>
+          <p:cNvPr id="4" name="Slide Number Placeholder 3">
+            <a:extLst>
+              <a:ext uri="{FF2B5EF4-FFF2-40B4-BE49-F238E27FC236}">
+                <a16:creationId xmlns:a16="http://schemas.microsoft.com/office/drawing/2014/main" id="{CA1F0878-1462-CE66-9BD6-0F2810621D90}"/>
+              </a:ext>
+            </a:extLst>
+          </p:cNvPr>
+          <p:cNvSpPr>
+            <a:spLocks noGrp="1"/>
+          </p:cNvSpPr>
+          <p:nvPr>
+            <p:ph type="sldNum" sz="quarter" idx="10"/>
+          </p:nvPr>
+        </p:nvSpPr>
+        <p:spPr/>
+        <p:txBody>
+          <a:bodyPr/>
+          <a:lstStyle/>
+          <a:p>
+            <a:fld id="{6CAAD981-78BF-409D-B3BA-8A6D32CEDE01}" type="slidenum">
+              <a:rPr lang="en-US" smtClean="0"/>
+              <a:pPr/>
+              <a:t>8</a:t>
+            </a:fld>
+            <a:endParaRPr lang="en-US"/>
+          </a:p>
+        </p:txBody>
+      </p:sp>
+    </p:spTree>
+    <p:extLst>
+      <p:ext uri="{BB962C8B-B14F-4D97-AF65-F5344CB8AC3E}">
+        <p14:creationId xmlns:p14="http://schemas.microsoft.com/office/powerpoint/2010/main" val="3811562204"/>
       </p:ext>
     </p:extLst>
   </p:cSld>
@@ -10052,12 +10320,22 @@
           </a:lstStyle>
           <a:p>
             <a:r>
-              <a:rPr lang="en-US" sz="2133" dirty="0">
+              <a:rPr lang="en-US" sz="2400" dirty="0"/>
+              <a:t>Leading smartphone OEMs (Apple, Samsung, Google).</a:t>
+            </a:r>
+          </a:p>
+          <a:p>
+            <a:r>
+              <a:rPr lang="en-US" sz="2400" dirty="0">
                 <a:latin typeface="Arial" panose="020B0604020202020204" pitchFamily="34" charset="0"/>
                 <a:cs typeface="Arial" panose="020B0604020202020204" pitchFamily="34" charset="0"/>
               </a:rPr>
-              <a:t>Smartphone Manufactures</a:t>
-            </a:r>
+              <a:t>Apple primary</a:t>
+            </a:r>
+            <a:endParaRPr lang="en-US" sz="2133" dirty="0">
+              <a:latin typeface="Arial" panose="020B0604020202020204" pitchFamily="34" charset="0"/>
+              <a:cs typeface="Arial" panose="020B0604020202020204" pitchFamily="34" charset="0"/>
+            </a:endParaRPr>
           </a:p>
         </p:txBody>
       </p:sp>
@@ -10173,23 +10451,7 @@
                 <a:latin typeface="Arial" panose="020B0604020202020204" pitchFamily="34" charset="0"/>
                 <a:cs typeface="Arial" panose="020B0604020202020204" pitchFamily="34" charset="0"/>
               </a:rPr>
-              <a:t>Co-Creation</a:t>
-            </a:r>
-          </a:p>
-          <a:p>
-            <a:pPr marL="152408" indent="-152408">
-              <a:buFont typeface="Arial" panose="020B0604020202020204" pitchFamily="34" charset="0"/>
-              <a:buChar char="•"/>
-            </a:pPr>
-            <a:r>
-              <a:rPr lang="en-US" sz="2133" dirty="0">
-                <a:solidFill>
-                  <a:srgbClr val="30813A"/>
-                </a:solidFill>
-                <a:latin typeface="Arial" panose="020B0604020202020204" pitchFamily="34" charset="0"/>
-                <a:cs typeface="Arial" panose="020B0604020202020204" pitchFamily="34" charset="0"/>
-              </a:rPr>
-              <a:t>Dedicated Assistance</a:t>
+              <a:t>Dedicated Assistance + Co-Creation</a:t>
             </a:r>
           </a:p>
           <a:p>
@@ -10244,7 +10506,7 @@
                 <a:latin typeface="Arial" panose="020B0604020202020204" pitchFamily="34" charset="0"/>
                 <a:cs typeface="Arial" panose="020B0604020202020204" pitchFamily="34" charset="0"/>
               </a:rPr>
-              <a:t>Asset Sales</a:t>
+              <a:t>Asset Sales of Filters</a:t>
             </a:r>
           </a:p>
           <a:p>
@@ -10260,7 +10522,7 @@
                 <a:latin typeface="Arial" panose="020B0604020202020204" pitchFamily="34" charset="0"/>
                 <a:cs typeface="Arial" panose="020B0604020202020204" pitchFamily="34" charset="0"/>
               </a:rPr>
-              <a:t>Volume of devices delivered on won sockets</a:t>
+              <a:t>Volume dependent price, negotiated</a:t>
             </a:r>
           </a:p>
         </p:txBody>
@@ -10485,6 +10747,29 @@
               <a:buChar char="•"/>
             </a:pPr>
             <a:r>
+              <a:rPr lang="en-US" sz="1867" dirty="0" err="1">
+                <a:solidFill>
+                  <a:srgbClr val="30813A"/>
+                </a:solidFill>
+                <a:latin typeface="Arial" panose="020B0604020202020204" pitchFamily="34" charset="0"/>
+                <a:cs typeface="Arial" panose="020B0604020202020204" pitchFamily="34" charset="0"/>
+              </a:rPr>
+              <a:t>CapEx</a:t>
+            </a:r>
+            <a:endParaRPr lang="en-US" sz="1867" dirty="0">
+              <a:solidFill>
+                <a:srgbClr val="30813A"/>
+              </a:solidFill>
+              <a:latin typeface="Arial" panose="020B0604020202020204" pitchFamily="34" charset="0"/>
+              <a:cs typeface="Arial" panose="020B0604020202020204" pitchFamily="34" charset="0"/>
+            </a:endParaRPr>
+          </a:p>
+          <a:p>
+            <a:pPr marL="609608" lvl="1" indent="-152408">
+              <a:buFont typeface="Arial" panose="020B0604020202020204" pitchFamily="34" charset="0"/>
+              <a:buChar char="•"/>
+            </a:pPr>
+            <a:r>
               <a:rPr lang="en-US" sz="1867" dirty="0">
                 <a:solidFill>
                   <a:srgbClr val="30813A"/>
@@ -10492,7 +10777,7 @@
                 <a:latin typeface="Arial" panose="020B0604020202020204" pitchFamily="34" charset="0"/>
                 <a:cs typeface="Arial" panose="020B0604020202020204" pitchFamily="34" charset="0"/>
               </a:rPr>
-              <a:t>Cash to operate</a:t>
+              <a:t>Working Capital</a:t>
             </a:r>
           </a:p>
           <a:p>
@@ -10631,7 +10916,7 @@
         </p:spPr>
         <p:txBody>
           <a:bodyPr wrap="square" rtlCol="0">
-            <a:normAutofit/>
+            <a:normAutofit fontScale="92500" lnSpcReduction="10000"/>
           </a:bodyPr>
           <a:lstStyle/>
           <a:p>
@@ -10679,7 +10964,7 @@
                 <a:latin typeface="Arial" panose="020B0604020202020204" pitchFamily="34" charset="0"/>
                 <a:cs typeface="Arial" panose="020B0604020202020204" pitchFamily="34" charset="0"/>
               </a:rPr>
-              <a:t>Contractors / Logistics</a:t>
+              <a:t>Facility Contractors / Logistics Vendors</a:t>
             </a:r>
           </a:p>
         </p:txBody>
@@ -10718,11 +11003,11 @@
                 <a:latin typeface="Arial" panose="020B0604020202020204" pitchFamily="34" charset="0"/>
                 <a:cs typeface="Arial" panose="020B0604020202020204" pitchFamily="34" charset="0"/>
               </a:rPr>
-              <a:t>Employee Salaries</a:t>
-            </a:r>
-          </a:p>
-          <a:p>
-            <a:pPr marL="152408" indent="-152408">
+              <a:t>Value-Driven</a:t>
+            </a:r>
+          </a:p>
+          <a:p>
+            <a:pPr marL="609608" lvl="1" indent="-152408">
               <a:buFont typeface="Arial" panose="020B0604020202020204" pitchFamily="34" charset="0"/>
               <a:buChar char="•"/>
             </a:pPr>
@@ -10734,11 +11019,11 @@
                 <a:latin typeface="Arial" panose="020B0604020202020204" pitchFamily="34" charset="0"/>
                 <a:cs typeface="Arial" panose="020B0604020202020204" pitchFamily="34" charset="0"/>
               </a:rPr>
-              <a:t>Equipment / Chemicals / consumables</a:t>
-            </a:r>
-          </a:p>
-          <a:p>
-            <a:pPr marL="152408" indent="-152408">
+              <a:t>Fixed Fab Costs</a:t>
+            </a:r>
+          </a:p>
+          <a:p>
+            <a:pPr marL="609608" lvl="1" indent="-152408">
               <a:buFont typeface="Arial" panose="020B0604020202020204" pitchFamily="34" charset="0"/>
               <a:buChar char="•"/>
             </a:pPr>
@@ -10750,7 +11035,7 @@
                 <a:latin typeface="Arial" panose="020B0604020202020204" pitchFamily="34" charset="0"/>
                 <a:cs typeface="Arial" panose="020B0604020202020204" pitchFamily="34" charset="0"/>
               </a:rPr>
-              <a:t>Contractors</a:t>
+              <a:t>Variable material costs</a:t>
             </a:r>
           </a:p>
         </p:txBody>
@@ -10873,7 +11158,7 @@
         <p:spPr/>
         <p:txBody>
           <a:bodyPr>
-            <a:normAutofit/>
+            <a:normAutofit fontScale="77500" lnSpcReduction="20000"/>
           </a:bodyPr>
           <a:lstStyle/>
           <a:p>
@@ -10886,7 +11171,47 @@
                 <a:latin typeface="Arial" panose="020B0604020202020204" pitchFamily="34" charset="0"/>
                 <a:cs typeface="Arial" panose="020B0604020202020204" pitchFamily="34" charset="0"/>
               </a:rPr>
-              <a:t>Explain your customer segments and why is this the case.</a:t>
+              <a:t>Customer Segments: Niche Smartphone OEM market. Not multi-sided or </a:t>
+            </a:r>
+            <a:r>
+              <a:rPr lang="en-US" dirty="0" err="1">
+                <a:latin typeface="Arial" panose="020B0604020202020204" pitchFamily="34" charset="0"/>
+                <a:cs typeface="Arial" panose="020B0604020202020204" pitchFamily="34" charset="0"/>
+              </a:rPr>
+              <a:t>diverisifed</a:t>
+            </a:r>
+            <a:r>
+              <a:rPr lang="en-US" dirty="0">
+                <a:latin typeface="Arial" panose="020B0604020202020204" pitchFamily="34" charset="0"/>
+                <a:cs typeface="Arial" panose="020B0604020202020204" pitchFamily="34" charset="0"/>
+              </a:rPr>
+              <a:t>. Relationships with Apple, Google, Samsung. Apple is the most important as their profitability is directly tied to ours.</a:t>
+            </a:r>
+          </a:p>
+          <a:p>
+            <a:pPr>
+              <a:buFont typeface="Arial" panose="020B0604020202020204" pitchFamily="34" charset="0"/>
+              <a:buChar char="•"/>
+            </a:pPr>
+            <a:r>
+              <a:rPr lang="en-US" dirty="0">
+                <a:latin typeface="Arial" panose="020B0604020202020204" pitchFamily="34" charset="0"/>
+                <a:cs typeface="Arial" panose="020B0604020202020204" pitchFamily="34" charset="0"/>
+              </a:rPr>
+              <a:t>Revenue Streams: Asset sale only. Pricing is negotiated when design sockets are won. Contracts offer production volume, and quality expectations within a single design cycle.</a:t>
+            </a:r>
+          </a:p>
+          <a:p>
+            <a:pPr>
+              <a:buFont typeface="Arial" panose="020B0604020202020204" pitchFamily="34" charset="0"/>
+              <a:buChar char="•"/>
+            </a:pPr>
+            <a:r>
+              <a:rPr lang="en-US" dirty="0">
+                <a:latin typeface="Arial" panose="020B0604020202020204" pitchFamily="34" charset="0"/>
+                <a:cs typeface="Arial" panose="020B0604020202020204" pitchFamily="34" charset="0"/>
+              </a:rPr>
+              <a:t>Resources:   </a:t>
             </a:r>
           </a:p>
           <a:p>
@@ -10895,37 +11220,11 @@
               <a:buChar char="•"/>
             </a:pPr>
             <a:r>
-              <a:rPr lang="en-US" sz="2400" dirty="0">
+              <a:rPr lang="en-US" dirty="0">
                 <a:latin typeface="Arial" panose="020B0604020202020204" pitchFamily="34" charset="0"/>
                 <a:cs typeface="Arial" panose="020B0604020202020204" pitchFamily="34" charset="0"/>
               </a:rPr>
-              <a:t>(Mass market, Niche market, Segmented, Diversified, Multi-sided)</a:t>
-            </a:r>
-          </a:p>
-          <a:p>
-            <a:pPr>
-              <a:buFont typeface="Arial" panose="020B0604020202020204" pitchFamily="34" charset="0"/>
-              <a:buChar char="•"/>
-            </a:pPr>
-            <a:r>
-              <a:rPr lang="en-US" dirty="0">
-                <a:latin typeface="Arial" panose="020B0604020202020204" pitchFamily="34" charset="0"/>
-                <a:cs typeface="Arial" panose="020B0604020202020204" pitchFamily="34" charset="0"/>
-              </a:rPr>
-              <a:t>List each revenue stream identified on your BMC and state the pricing mechanism used for that stream.</a:t>
-            </a:r>
-          </a:p>
-          <a:p>
-            <a:pPr>
-              <a:buFont typeface="Arial" panose="020B0604020202020204" pitchFamily="34" charset="0"/>
-              <a:buChar char="•"/>
-            </a:pPr>
-            <a:r>
-              <a:rPr lang="en-US" dirty="0">
-                <a:latin typeface="Arial" panose="020B0604020202020204" pitchFamily="34" charset="0"/>
-                <a:cs typeface="Arial" panose="020B0604020202020204" pitchFamily="34" charset="0"/>
-              </a:rPr>
-              <a:t>List each key resource and specify which of the four general categories that resource belongs in.</a:t>
+              <a:t>Physical: The fab, equipment, and chemicals ensure we have the resources needed to actually build a product. </a:t>
             </a:r>
           </a:p>
           <a:p>
@@ -10938,11 +11237,62 @@
                 <a:latin typeface="Arial" panose="020B0604020202020204" pitchFamily="34" charset="0"/>
                 <a:cs typeface="Arial" panose="020B0604020202020204" pitchFamily="34" charset="0"/>
               </a:rPr>
-              <a:t>Why do you believe this is?</a:t>
-            </a:r>
-          </a:p>
-          <a:p>
-            <a:pPr>
+              <a:t>Intellectual: Process knowledge, Patents, and IP is why we win apples contracts </a:t>
+            </a:r>
+          </a:p>
+          <a:p>
+            <a:pPr lvl="1">
+              <a:buFont typeface="Arial" panose="020B0604020202020204" pitchFamily="34" charset="0"/>
+              <a:buChar char="•"/>
+            </a:pPr>
+            <a:r>
+              <a:rPr lang="en-US" dirty="0">
+                <a:latin typeface="Arial" panose="020B0604020202020204" pitchFamily="34" charset="0"/>
+                <a:cs typeface="Arial" panose="020B0604020202020204" pitchFamily="34" charset="0"/>
+              </a:rPr>
+              <a:t>Human: Humans run the plant. Without 24/7 operation production stops, utilization goes down, profitability drops. </a:t>
+            </a:r>
+          </a:p>
+          <a:p>
+            <a:pPr lvl="1">
+              <a:buFont typeface="Arial" panose="020B0604020202020204" pitchFamily="34" charset="0"/>
+              <a:buChar char="•"/>
+            </a:pPr>
+            <a:r>
+              <a:rPr lang="en-US" dirty="0">
+                <a:latin typeface="Arial" panose="020B0604020202020204" pitchFamily="34" charset="0"/>
+                <a:cs typeface="Arial" panose="020B0604020202020204" pitchFamily="34" charset="0"/>
+              </a:rPr>
+              <a:t>Financial: Working capital and </a:t>
+            </a:r>
+            <a:r>
+              <a:rPr lang="en-US" dirty="0" err="1">
+                <a:latin typeface="Arial" panose="020B0604020202020204" pitchFamily="34" charset="0"/>
+                <a:cs typeface="Arial" panose="020B0604020202020204" pitchFamily="34" charset="0"/>
+              </a:rPr>
+              <a:t>CapEx</a:t>
+            </a:r>
+            <a:r>
+              <a:rPr lang="en-US" dirty="0">
+                <a:latin typeface="Arial" panose="020B0604020202020204" pitchFamily="34" charset="0"/>
+                <a:cs typeface="Arial" panose="020B0604020202020204" pitchFamily="34" charset="0"/>
+              </a:rPr>
+              <a:t> investments drive cost-reduction goals and innovation projects </a:t>
+            </a:r>
+            <a:r>
+              <a:rPr lang="en-US">
+                <a:latin typeface="Arial" panose="020B0604020202020204" pitchFamily="34" charset="0"/>
+                <a:cs typeface="Arial" panose="020B0604020202020204" pitchFamily="34" charset="0"/>
+              </a:rPr>
+              <a:t>that drive COGS. </a:t>
+            </a:r>
+            <a:endParaRPr lang="en-US" dirty="0">
+              <a:latin typeface="Arial" panose="020B0604020202020204" pitchFamily="34" charset="0"/>
+              <a:cs typeface="Arial" panose="020B0604020202020204" pitchFamily="34" charset="0"/>
+            </a:endParaRPr>
+          </a:p>
+          <a:p>
+            <a:pPr lvl="1">
               <a:buFont typeface="Arial" panose="020B0604020202020204" pitchFamily="34" charset="0"/>
               <a:buChar char="•"/>
             </a:pPr>
@@ -10957,6 +11307,169 @@
     <p:extLst>
       <p:ext uri="{BB962C8B-B14F-4D97-AF65-F5344CB8AC3E}">
         <p14:creationId xmlns:p14="http://schemas.microsoft.com/office/powerpoint/2010/main" val="1848747055"/>
+      </p:ext>
+    </p:extLst>
+  </p:cSld>
+  <p:clrMapOvr>
+    <a:masterClrMapping/>
+  </p:clrMapOvr>
+</p:sld>
+</file>
+
+<file path=ppt/slides/slide8.xml><?xml version="1.0" encoding="utf-8"?>
+<p:sld xmlns:a="http://schemas.openxmlformats.org/drawingml/2006/main" xmlns:r="http://schemas.openxmlformats.org/officeDocument/2006/relationships" xmlns:p="http://schemas.openxmlformats.org/presentationml/2006/main">
+  <p:cSld>
+    <p:spTree>
+      <p:nvGrpSpPr>
+        <p:cNvPr id="1" name="">
+          <a:extLst>
+            <a:ext uri="{FF2B5EF4-FFF2-40B4-BE49-F238E27FC236}">
+              <a16:creationId xmlns:a16="http://schemas.microsoft.com/office/drawing/2014/main" id="{5D90ACD9-09E1-525C-DF7F-2198B09676FD}"/>
+            </a:ext>
+          </a:extLst>
+        </p:cNvPr>
+        <p:cNvGrpSpPr/>
+        <p:nvPr/>
+      </p:nvGrpSpPr>
+      <p:grpSpPr>
+        <a:xfrm>
+          <a:off x="0" y="0"/>
+          <a:ext cx="0" cy="0"/>
+          <a:chOff x="0" y="0"/>
+          <a:chExt cx="0" cy="0"/>
+        </a:xfrm>
+      </p:grpSpPr>
+      <p:sp>
+        <p:nvSpPr>
+          <p:cNvPr id="2" name="Title 1">
+            <a:extLst>
+              <a:ext uri="{FF2B5EF4-FFF2-40B4-BE49-F238E27FC236}">
+                <a16:creationId xmlns:a16="http://schemas.microsoft.com/office/drawing/2014/main" id="{40C1EAC2-5312-1E2E-919C-A0E6242B2249}"/>
+              </a:ext>
+            </a:extLst>
+          </p:cNvPr>
+          <p:cNvSpPr>
+            <a:spLocks noGrp="1"/>
+          </p:cNvSpPr>
+          <p:nvPr>
+            <p:ph type="title"/>
+          </p:nvPr>
+        </p:nvSpPr>
+        <p:spPr/>
+        <p:txBody>
+          <a:bodyPr/>
+          <a:lstStyle/>
+          <a:p>
+            <a:r>
+              <a:rPr lang="en-US" dirty="0"/>
+              <a:t>Additional BMC Detail</a:t>
+            </a:r>
+          </a:p>
+        </p:txBody>
+      </p:sp>
+      <p:sp>
+        <p:nvSpPr>
+          <p:cNvPr id="3" name="Content Placeholder 2">
+            <a:extLst>
+              <a:ext uri="{FF2B5EF4-FFF2-40B4-BE49-F238E27FC236}">
+                <a16:creationId xmlns:a16="http://schemas.microsoft.com/office/drawing/2014/main" id="{FF5A9467-C37C-FD7E-39D5-49964AE2597C}"/>
+              </a:ext>
+            </a:extLst>
+          </p:cNvPr>
+          <p:cNvSpPr>
+            <a:spLocks noGrp="1"/>
+          </p:cNvSpPr>
+          <p:nvPr>
+            <p:ph idx="1"/>
+          </p:nvPr>
+        </p:nvSpPr>
+        <p:spPr/>
+        <p:txBody>
+          <a:bodyPr>
+            <a:normAutofit/>
+          </a:bodyPr>
+          <a:lstStyle/>
+          <a:p>
+            <a:pPr>
+              <a:buFont typeface="Arial" panose="020B0604020202020204" pitchFamily="34" charset="0"/>
+              <a:buChar char="•"/>
+            </a:pPr>
+            <a:r>
+              <a:rPr lang="en-US" dirty="0">
+                <a:latin typeface="Arial" panose="020B0604020202020204" pitchFamily="34" charset="0"/>
+                <a:cs typeface="Arial" panose="020B0604020202020204" pitchFamily="34" charset="0"/>
+              </a:rPr>
+              <a:t>Explain your customer segments and why is this the case.</a:t>
+            </a:r>
+          </a:p>
+          <a:p>
+            <a:pPr lvl="1">
+              <a:buFont typeface="Arial" panose="020B0604020202020204" pitchFamily="34" charset="0"/>
+              <a:buChar char="•"/>
+            </a:pPr>
+            <a:r>
+              <a:rPr lang="en-US" sz="2400" dirty="0">
+                <a:latin typeface="Arial" panose="020B0604020202020204" pitchFamily="34" charset="0"/>
+                <a:cs typeface="Arial" panose="020B0604020202020204" pitchFamily="34" charset="0"/>
+              </a:rPr>
+              <a:t>(Mass market, Niche market, Segmented, Diversified, Multi-sided)</a:t>
+            </a:r>
+          </a:p>
+          <a:p>
+            <a:pPr>
+              <a:buFont typeface="Arial" panose="020B0604020202020204" pitchFamily="34" charset="0"/>
+              <a:buChar char="•"/>
+            </a:pPr>
+            <a:r>
+              <a:rPr lang="en-US" dirty="0">
+                <a:latin typeface="Arial" panose="020B0604020202020204" pitchFamily="34" charset="0"/>
+                <a:cs typeface="Arial" panose="020B0604020202020204" pitchFamily="34" charset="0"/>
+              </a:rPr>
+              <a:t>List each revenue stream identified on your BMC and state the pricing mechanism used for that stream.</a:t>
+            </a:r>
+          </a:p>
+          <a:p>
+            <a:pPr>
+              <a:buFont typeface="Arial" panose="020B0604020202020204" pitchFamily="34" charset="0"/>
+              <a:buChar char="•"/>
+            </a:pPr>
+            <a:r>
+              <a:rPr lang="en-US" dirty="0">
+                <a:latin typeface="Arial" panose="020B0604020202020204" pitchFamily="34" charset="0"/>
+                <a:cs typeface="Arial" panose="020B0604020202020204" pitchFamily="34" charset="0"/>
+              </a:rPr>
+              <a:t>List each key resource and specify which of the four general categories that resource belongs in.</a:t>
+            </a:r>
+          </a:p>
+          <a:p>
+            <a:pPr lvl="1">
+              <a:buFont typeface="Arial" panose="020B0604020202020204" pitchFamily="34" charset="0"/>
+              <a:buChar char="•"/>
+            </a:pPr>
+            <a:r>
+              <a:rPr lang="en-US" dirty="0">
+                <a:latin typeface="Arial" panose="020B0604020202020204" pitchFamily="34" charset="0"/>
+                <a:cs typeface="Arial" panose="020B0604020202020204" pitchFamily="34" charset="0"/>
+              </a:rPr>
+              <a:t>Why do you believe this is?</a:t>
+            </a:r>
+          </a:p>
+          <a:p>
+            <a:pPr>
+              <a:buFont typeface="Arial" panose="020B0604020202020204" pitchFamily="34" charset="0"/>
+              <a:buChar char="•"/>
+            </a:pPr>
+            <a:endParaRPr lang="en-US" dirty="0">
+              <a:latin typeface="Arial" panose="020B0604020202020204" pitchFamily="34" charset="0"/>
+              <a:cs typeface="Arial" panose="020B0604020202020204" pitchFamily="34" charset="0"/>
+            </a:endParaRPr>
+          </a:p>
+        </p:txBody>
+      </p:sp>
+    </p:spTree>
+    <p:extLst>
+      <p:ext uri="{BB962C8B-B14F-4D97-AF65-F5344CB8AC3E}">
+        <p14:creationId xmlns:p14="http://schemas.microsoft.com/office/powerpoint/2010/main" val="2158991779"/>
       </p:ext>
     </p:extLst>
   </p:cSld>

</xml_diff>